<commit_message>
docs: rename intro slide and add benchmark table vs real PR review apps
</commit_message>
<xml_diff>
--- a/docs/presentation-slides.pptx
+++ b/docs/presentation-slides.pptx
@@ -596,7 +596,7 @@
           <a:p>
             <a:r>
               <a:rPr lang="en-US" dirty="0"/>
-              <a:t>Slide 2: Introduction</a:t>
+              <a:t>Slide 2: Problem &amp; Solution</a:t>
             </a:r>
             <a:endParaRPr lang="en-US" dirty="0"/>
           </a:p>
@@ -772,7 +772,7 @@
           <a:p>
             <a:r>
               <a:rPr lang="en-US" dirty="0"/>
-              <a:t>Slide 4: What's different from other PR review apps</a:t>
+              <a:t>Slide 4: Benchmark vs other PR review apps</a:t>
             </a:r>
             <a:endParaRPr lang="en-US" dirty="0"/>
           </a:p>

</xml_diff>